<commit_message>
Correct presentation credits and repository link
</commit_message>
<xml_diff>
--- a/docs/presentation.pptx
+++ b/docs/presentation.pptx
@@ -2031,7 +2031,7 @@
                 <a:ea typeface="Malgun Gothic" pitchFamily="34" charset="-122"/>
                 <a:cs typeface="Malgun Gothic" pitchFamily="34" charset="-120"/>
               </a:rPr>
-              <a:t>팀원 3인 · 김다빈(기획/UX) · 김진아(개발) · 이승민(검증/문서)</a:t>
+              <a:t>팀원 3인 · 김다빈(기획/UX) · 김진아(개발) · 안승민(검증/문서)</a:t>
             </a:r>
             <a:endParaRPr lang="en-US" sz="1200" dirty="0"/>
           </a:p>
@@ -4889,7 +4889,7 @@
         <p:spPr>
           <a:xfrm>
             <a:off x="640080" y="777240"/>
-            <a:ext cx="5486400" cy="548640"/>
+            <a:ext cx="8138160" cy="548640"/>
           </a:xfrm>
           <a:prstGeom prst="rect">
             <a:avLst/>
@@ -5345,7 +5345,7 @@
                 <a:ea typeface="Malgun Gothic" pitchFamily="34" charset="-122"/>
                 <a:cs typeface="Malgun Gothic" pitchFamily="34" charset="-120"/>
               </a:rPr>
-              <a:t>이승민</a:t>
+              <a:t>안승민</a:t>
             </a:r>
             <a:endParaRPr lang="en-US" sz="1200" dirty="0"/>
           </a:p>
@@ -5681,7 +5681,7 @@
                 <a:ea typeface="Malgun Gothic" pitchFamily="34" charset="-122"/>
                 <a:cs typeface="Malgun Gothic" pitchFamily="34" charset="-120"/>
               </a:rPr>
-              <a:t>github.com/80gina/MM</a:t>
+              <a:t>github.com/codyssey-seungmin/M2-1</a:t>
             </a:r>
             <a:endParaRPr lang="en-US" sz="650" dirty="0"/>
           </a:p>

</xml_diff>